<commit_message>
feat: add day 10 release readiness gate
</commit_message>
<xml_diff>
--- a/output/tech-spike/concept-package.pptx
+++ b/output/tech-spike/concept-package.pptx
@@ -3136,7 +3136,7 @@
         <p:spPr>
           <a:xfrm>
             <a:off x="640080" y="1234440"/>
-            <a:ext cx="6949440" cy="5212080"/>
+            <a:ext cx="5669280" cy="4251960"/>
           </a:xfrm>
           <a:prstGeom prst="rect">
             <a:avLst/>
@@ -3151,8 +3151,8 @@
         </p:nvSpPr>
         <p:spPr>
           <a:xfrm>
-            <a:off x="7955279" y="1463040"/>
-            <a:ext cx="3657600" cy="2743200"/>
+            <a:off x="6583680" y="1417320"/>
+            <a:ext cx="2103120" cy="3840480"/>
           </a:xfrm>
           <a:prstGeom prst="rect">
             <a:avLst/>
@@ -3165,11 +3165,17 @@
           </a:bodyPr>
           <a:lstStyle/>
           <a:p>
+            <a:pPr>
+              <a:defRPr sz="1500"/>
+            </a:pPr>
             <a:r>
               <a:t>地块面积</a:t>
             </a:r>
           </a:p>
           <a:p>
+            <a:pPr>
+              <a:defRPr sz="1500"/>
+            </a:pPr>
             <a:r>
               <a:t>432.0 m²</a:t>
             </a:r>
@@ -3179,6 +3185,7 @@
               <a:spcBef>
                 <a:spcPts val="1400"/>
               </a:spcBef>
+              <a:defRPr sz="1300"/>
             </a:pPr>
             <a:r>
               <a:t>周长 84.0 m</a:t>
@@ -3189,6 +3196,7 @@
               <a:spcBef>
                 <a:spcPts val="1400"/>
               </a:spcBef>
+              <a:defRPr sz="1300"/>
             </a:pPr>
             <a:r>
               <a:t>输出：PNG / OBJ / PPTX / PDF</a:t>
@@ -3199,6 +3207,7 @@
               <a:spcBef>
                 <a:spcPts val="1400"/>
               </a:spcBef>
+              <a:defRPr sz="1300"/>
             </a:pPr>
             <a:r>
               <a:t>仅用于概念验证，不可直接施工</a:t>

</xml_diff>